<commit_message>
Weekly brief: CPT-only calibration finding in section 07 (page, script, PPT)
</commit_message>
<xml_diff>
--- a/docs/Topic6_WeeklyReport.pptx
+++ b/docs/Topic6_WeeklyReport.pptx
@@ -14088,6 +14088,34 @@
                 <a:latin typeface="Noto Sans SC"/>
               </a:rPr>
               <a:t>这是第三阶段「对齐」要打的靶子：先试成本最低的按标签重新平衡的 SFT，不行再上 DPO。</a:t>
+            </a:r>
+          </a:p>
+          <a:p>
+            <a:pPr algn="l">
+              <a:lnSpc>
+                <a:spcPct val="135000"/>
+              </a:lnSpc>
+              <a:spcAft>
+                <a:spcPts val="800"/>
+              </a:spcAft>
+            </a:pPr>
+            <a:r>
+              <a:rPr sz="1250" b="1">
+                <a:solidFill>
+                  <a:srgbClr val="14263B"/>
+                </a:solidFill>
+                <a:latin typeface="Noto Sans SC"/>
+              </a:rPr>
+              <a:t>偏置是 SFT 带进来的，不是 CPT。</a:t>
+            </a:r>
+            <a:r>
+              <a:rPr sz="1250" b="0">
+                <a:solidFill>
+                  <a:srgbClr val="3D4E63"/>
+                </a:solidFill>
+                <a:latin typeface="Noto Sans SC"/>
+              </a:rPr>
+              <a:t>只做 CPT 不做 SFT 的 B2 adapter 答 yes / no / maybe 598 / 288 / 114，五个模型里最接近真实分布；一做短答式 SFT，maybe 就塌下去。对齐要改的是 SFT 的数据配比。</a:t>
             </a:r>
           </a:p>
         </p:txBody>

</xml_diff>